<commit_message>
Clarify LIT-MOM-01.1 inference and sleeves
</commit_message>
<xml_diff>
--- a/literature_studies/presentations/gen5_lit_mom_01_1_interday_momentum_evidence.pptx
+++ b/literature_studies/presentations/gen5_lit_mom_01_1_interday_momentum_evidence.pptx
@@ -2,26 +2,26 @@
 <file path=ppt/presentation.xml><?xml version="1.0" encoding="utf-8"?>
 <p:presentation xmlns:p="http://schemas.openxmlformats.org/presentationml/2006/main">
   <p:sldMasterIdLst>
-    <p:sldMasterId xmlns:r="http://schemas.openxmlformats.org/officeDocument/2006/relationships" id="2147483648" r:id="Ree9fca7d85e6449c"/>
+    <p:sldMasterId xmlns:r="http://schemas.openxmlformats.org/officeDocument/2006/relationships" id="2147483648" r:id="Rfaa86265d23a4d3f"/>
   </p:sldMasterIdLst>
   <p:notesMasterIdLst>
-    <p:notesMasterId xmlns:r="http://schemas.openxmlformats.org/officeDocument/2006/relationships" r:id="R9c454d1bec744c06"/>
+    <p:notesMasterId xmlns:r="http://schemas.openxmlformats.org/officeDocument/2006/relationships" r:id="R13ee35cc556e44c0"/>
   </p:notesMasterIdLst>
   <p:sldIdLst>
-    <p:sldId xmlns:r="http://schemas.openxmlformats.org/officeDocument/2006/relationships" id="256" r:id="Rf25f8130c1a94689"/>
-    <p:sldId xmlns:r="http://schemas.openxmlformats.org/officeDocument/2006/relationships" id="257" r:id="R340d4b8b3a994e97"/>
-    <p:sldId xmlns:r="http://schemas.openxmlformats.org/officeDocument/2006/relationships" id="258" r:id="R98aff73773ac470b"/>
-    <p:sldId xmlns:r="http://schemas.openxmlformats.org/officeDocument/2006/relationships" id="259" r:id="R4c396558efe34c16"/>
-    <p:sldId xmlns:r="http://schemas.openxmlformats.org/officeDocument/2006/relationships" id="260" r:id="Ree7cbe61bc8e4835"/>
-    <p:sldId xmlns:r="http://schemas.openxmlformats.org/officeDocument/2006/relationships" id="261" r:id="Rcd6c9a4db6ff4efb"/>
-    <p:sldId xmlns:r="http://schemas.openxmlformats.org/officeDocument/2006/relationships" id="262" r:id="R97d988102d294f95"/>
-    <p:sldId xmlns:r="http://schemas.openxmlformats.org/officeDocument/2006/relationships" id="263" r:id="R479c6111bc894d1c"/>
-    <p:sldId xmlns:r="http://schemas.openxmlformats.org/officeDocument/2006/relationships" id="264" r:id="Rcd34c39cd1ff4add"/>
-    <p:sldId xmlns:r="http://schemas.openxmlformats.org/officeDocument/2006/relationships" id="265" r:id="Rdc5c2dbf82d848c9"/>
-    <p:sldId xmlns:r="http://schemas.openxmlformats.org/officeDocument/2006/relationships" id="266" r:id="Rf5d5e69bedaa414e"/>
-    <p:sldId xmlns:r="http://schemas.openxmlformats.org/officeDocument/2006/relationships" id="267" r:id="R518f9a9740a544d6"/>
-    <p:sldId xmlns:r="http://schemas.openxmlformats.org/officeDocument/2006/relationships" id="268" r:id="Ra31d76ff7ae64443"/>
-    <p:sldId xmlns:r="http://schemas.openxmlformats.org/officeDocument/2006/relationships" id="269" r:id="Rca6db9d4e5854d91"/>
+    <p:sldId xmlns:r="http://schemas.openxmlformats.org/officeDocument/2006/relationships" id="256" r:id="R5d9648cc1f5f49d9"/>
+    <p:sldId xmlns:r="http://schemas.openxmlformats.org/officeDocument/2006/relationships" id="257" r:id="R6e6ad08d5c354a41"/>
+    <p:sldId xmlns:r="http://schemas.openxmlformats.org/officeDocument/2006/relationships" id="258" r:id="Rc16f261de4854376"/>
+    <p:sldId xmlns:r="http://schemas.openxmlformats.org/officeDocument/2006/relationships" id="259" r:id="Rea9fb14c1d3548db"/>
+    <p:sldId xmlns:r="http://schemas.openxmlformats.org/officeDocument/2006/relationships" id="260" r:id="R915a0ad1419b4ae2"/>
+    <p:sldId xmlns:r="http://schemas.openxmlformats.org/officeDocument/2006/relationships" id="261" r:id="R40a63437929a4786"/>
+    <p:sldId xmlns:r="http://schemas.openxmlformats.org/officeDocument/2006/relationships" id="262" r:id="R455dc8fbae35499e"/>
+    <p:sldId xmlns:r="http://schemas.openxmlformats.org/officeDocument/2006/relationships" id="263" r:id="R4693fbc5cb444688"/>
+    <p:sldId xmlns:r="http://schemas.openxmlformats.org/officeDocument/2006/relationships" id="264" r:id="R23821bdeaf024e94"/>
+    <p:sldId xmlns:r="http://schemas.openxmlformats.org/officeDocument/2006/relationships" id="265" r:id="Rbf0a42662f8b4bea"/>
+    <p:sldId xmlns:r="http://schemas.openxmlformats.org/officeDocument/2006/relationships" id="266" r:id="Rc68e99e2c3434856"/>
+    <p:sldId xmlns:r="http://schemas.openxmlformats.org/officeDocument/2006/relationships" id="267" r:id="R788621e504394e69"/>
+    <p:sldId xmlns:r="http://schemas.openxmlformats.org/officeDocument/2006/relationships" id="268" r:id="Rbbbc2a36caca47a1"/>
+    <p:sldId xmlns:r="http://schemas.openxmlformats.org/officeDocument/2006/relationships" id="269" r:id="R3250356102e34e1b"/>
   </p:sldIdLst>
   <p:sldSz cx="12192000" cy="6858000"/>
   <p:notesSz cx="6858000" cy="9144000"/>
@@ -845,7 +845,7 @@
           <a:lstStyle xmlns:a="http://schemas.openxmlformats.org/drawingml/2006/main"/>
           <a:p xmlns:a="http://schemas.openxmlformats.org/drawingml/2006/main">
             <a:r>
-              <a:t>Completed long sleeves averaged negative 0.087% after primary costs with 47.2% directional accuracy; short sleeves averaged negative 0.084% with 51.1% accuracy. Calendar returns were negative 1.38% in 2021, positive 1.35% in 2022, and positive 0.13% in 2023.</a:t>
+              <a:t>TRAIN was asymmetric: 770 long sleeves were 60.3% directionally correct and averaged +5.1 bp gross, while 212 short sleeves were 44.8% correct and slightly negative gross. In OOS, long accuracy fell to 47.2%; short accuracy was 51.1%. Both directions were mildly positive gross but averaged about -8 to -9 bp after the frozen primary round-trip cost. This is why direction prediction and implementable P&amp;L must be audited separately.</a:t>
             </a:r>
           </a:p>
           <a:p xmlns:a="http://schemas.openxmlformats.org/drawingml/2006/main">
@@ -865,17 +865,17 @@
           </a:p>
           <a:p xmlns:a="http://schemas.openxmlformats.org/drawingml/2006/main">
             <a:r>
+              <a:t>- C:/Users/Franc/OneDrive/Documents/Francis/Peltata Project/Time-Series-Modeling-Gen5/runs/research_workbench/literature_grounded/lit_mom_01_1_interday_momentum_20260730_v6/train_completed_sleeves.csv</a:t>
+            </a:r>
+          </a:p>
+          <a:p xmlns:a="http://schemas.openxmlformats.org/drawingml/2006/main">
+            <a:r>
               <a:t>- C:/Users/Franc/OneDrive/Documents/Francis/Peltata Project/Time-Series-Modeling-Gen5/runs/research_workbench/literature_grounded/lit_mom_01_1_interday_momentum_20260730_v6/development_completed_sleeves.csv</a:t>
             </a:r>
           </a:p>
           <a:p xmlns:a="http://schemas.openxmlformats.org/drawingml/2006/main">
             <a:r>
-              <a:t>- C:/Users/Franc/OneDrive/Documents/Francis/Peltata Project/Time-Series-Modeling-Gen5/runs/research_workbench/literature_grounded/lit_mom_01_1_interday_momentum_20260730_v6/development_calendar_year_returns.csv</a:t>
-            </a:r>
-          </a:p>
-          <a:p xmlns:a="http://schemas.openxmlformats.org/drawingml/2006/main">
-            <a:r>
-              <a:t>- C:/Users/Franc/OneDrive/Documents/Francis/Peltata Project/Time-Series-Modeling-Gen5/runs/research_workbench/literature_grounded/lit_mom_01_1_interday_momentum_20260730_v6/visuals/development_sleeve_and_year_summary.png</a:t>
+              <a:t>- C:/Users/Franc/OneDrive/Documents/Francis/Peltata Project/Time-Series-Modeling-Gen5/literature_studies/scripts/render_gen5_lit_mom_01_1_revisit_audit.R</a:t>
             </a:r>
           </a:p>
         </p:txBody>
@@ -1140,7 +1140,7 @@
           <a:lstStyle xmlns:a="http://schemas.openxmlformats.org/drawingml/2006/main"/>
           <a:p xmlns:a="http://schemas.openxmlformats.org/drawingml/2006/main">
             <a:r>
-              <a:t>Chan's prose and Figure 6.1 use anchors separated by the shorter horizon. For 250/25 that is 25 sessions: future 25-session outcomes do not overlap, but the 250-session predictors still do. A strict L+H sensitivity is more independent but sharply reduces sample size. The printed MATLAB loop advances by max(L,H), which conflicts with the prose and figure; the deck records rather than hides that inconsistency.</a:t>
+              <a:t>CHAN_MIN_STEP advances by min(L,H), which preserves more pairs and makes the shorter leg non-overlapping. STEP_L is a useful Gen5 diagnostic for distinct formation episodes, but it does not make observations fully independent: H outcomes can overlap, and when H&lt;L a future outcome can enter the next formation window. A fixed STEP_L partition also depends on its starting phase. L+H is the strongest raw-interval separation but is often too sparse.</a:t>
             </a:r>
           </a:p>
           <a:p xmlns:a="http://schemas.openxmlformats.org/drawingml/2006/main">
@@ -1165,12 +1165,7 @@
           </a:p>
           <a:p xmlns:a="http://schemas.openxmlformats.org/drawingml/2006/main">
             <a:r>
-              <a:t>- C:/Users/Franc/OneDrive/Documents/Francis/Peltata Project/Time-Series-Modeling-Gen5/literature_studies/docs/GEN5_LITERATURE_SOURCE_LEDGER.md</a:t>
-            </a:r>
-          </a:p>
-          <a:p xmlns:a="http://schemas.openxmlformats.org/drawingml/2006/main">
-            <a:r>
-              <a:t>- C:/Users/Franc/OneDrive/Documents/Francis/Peltata Project/Time-Series-Modeling-Gen5/runs/research_workbench/literature_grounded/lit_mom_01_1_interday_momentum_20260730_v6/train_correlation_summary.csv</a:t>
+              <a:t>- C:/Users/Franc/OneDrive/Documents/Francis/Peltata Project/Time-Series-Modeling-Gen5/literature_studies/docs/GEN5_LIT_MOM_01_1_INTERDAY_MOMENTUM_RESULTS.md</a:t>
             </a:r>
           </a:p>
         </p:txBody>
@@ -1335,7 +1330,7 @@
           <a:lstStyle xmlns:a="http://schemas.openxmlformats.org/drawingml/2006/main"/>
           <a:p xmlns:a="http://schemas.openxmlformats.org/drawingml/2006/main">
             <a:r>
-              <a:t>The portfolio does not flip the whole account on one close. Each session contributes one equal sleeve, so exposure ramps as old sleeves expire and new sleeves enter. The selected SHY rule uses L=60 and H=5; Chan's canonical reference uses L=250 and H=25.</a:t>
+              <a:t>The key correction is that the strategy does not spread one Day-0 forecast across H entries. It recalculates after every close. Each resulting signal starts one new 1/H sleeve at the next open, and each sleeve has its own H-session life. Adjacent L-session signals share L-1 observations, so repeated signs are highly correlated updates rather than independent confirmations.</a:t>
             </a:r>
           </a:p>
           <a:p xmlns:a="http://schemas.openxmlformats.org/drawingml/2006/main">
@@ -1360,12 +1355,17 @@
           </a:p>
           <a:p xmlns:a="http://schemas.openxmlformats.org/drawingml/2006/main">
             <a:r>
-              <a:t>- C:/Users/Franc/OneDrive/Documents/Francis/Peltata Project/Time-Series-Modeling-Gen5/runs/research_workbench/literature_grounded/lit_mom_01_1_interday_momentum_20260730_v6/train_bar_replay.csv</a:t>
-            </a:r>
-          </a:p>
-          <a:p xmlns:a="http://schemas.openxmlformats.org/drawingml/2006/main">
-            <a:r>
-              <a:t>- C:/Users/Franc/OneDrive/Documents/Francis/Peltata Project/Time-Series-Modeling-Gen5/runs/research_workbench/literature_grounded/lit_mom_01_1_interday_momentum_20260730_v6/visuals/train_exposure_tape.png</a:t>
+              <a:t>- C:/Users/Franc/OneDrive/Documents/Francis/Peltata Project/Time-Series-Modeling-Gen5/runs/research_workbench/literature_grounded/lit_mom_01_1_interday_momentum_20260730_v6/development_completed_sleeves.csv</a:t>
+            </a:r>
+          </a:p>
+          <a:p xmlns:a="http://schemas.openxmlformats.org/drawingml/2006/main">
+            <a:r>
+              <a:t>- C:/Users/Franc/OneDrive/Documents/Francis/Peltata Project/Time-Series-Modeling-Gen5/runs/research_workbench/literature_grounded/lit_mom_01_1_interday_momentum_20260730_v6/development_bar_replay.csv</a:t>
+            </a:r>
+          </a:p>
+          <a:p xmlns:a="http://schemas.openxmlformats.org/drawingml/2006/main">
+            <a:r>
+              <a:t>- C:/Users/Franc/OneDrive/Documents/Francis/Peltata Project/Time-Series-Modeling-Gen5/literature_studies/scripts/render_gen5_lit_mom_01_1_revisit_audit.R</a:t>
             </a:r>
           </a:p>
         </p:txBody>
@@ -1828,7 +1828,7 @@
   </p:cSld>
   <p:clrMap bg1="lt1" tx1="dk1" bg2="lt2" tx2="dk2" accent1="accent1" accent2="accent2" accent3="accent3" accent4="accent4" accent5="accent5" accent6="accent6" hlink="hlink" folHlink="folHlink"/>
   <p:sldLayoutIdLst>
-    <p:sldLayoutId xmlns:r="http://schemas.openxmlformats.org/officeDocument/2006/relationships" id="2147483649" r:id="R23984a33cb544d2b"/>
+    <p:sldLayoutId xmlns:r="http://schemas.openxmlformats.org/officeDocument/2006/relationships" id="2147483649" r:id="R662655f1d1644bac"/>
   </p:sldLayoutIdLst>
   <p:txStyles>
     <p:titleStyle>
@@ -2818,7 +2818,7 @@
           <p:nvPr/>
         </p:nvPicPr>
         <p:blipFill>
-          <a:blip xmlns:r="http://schemas.openxmlformats.org/officeDocument/2006/relationships" xmlns:a="http://schemas.openxmlformats.org/drawingml/2006/main" r:embed="R72f27ff935f843da"/>
+          <a:blip xmlns:r="http://schemas.openxmlformats.org/officeDocument/2006/relationships" xmlns:a="http://schemas.openxmlformats.org/drawingml/2006/main" r:embed="R4361224cdccc47df"/>
           <a:stretch xmlns:a="http://schemas.openxmlformats.org/drawingml/2006/main"/>
         </p:blipFill>
         <p:spPr>
@@ -2952,7 +2952,7 @@
           <p:nvPr/>
         </p:nvPicPr>
         <p:blipFill>
-          <a:blip xmlns:r="http://schemas.openxmlformats.org/officeDocument/2006/relationships" xmlns:a="http://schemas.openxmlformats.org/drawingml/2006/main" r:embed="Rb3bed2f309eb477f"/>
+          <a:blip xmlns:r="http://schemas.openxmlformats.org/officeDocument/2006/relationships" xmlns:a="http://schemas.openxmlformats.org/drawingml/2006/main" r:embed="Rf5580eb04aee4dec"/>
           <a:stretch xmlns:a="http://schemas.openxmlformats.org/drawingml/2006/main"/>
         </p:blipFill>
         <p:spPr>
@@ -3072,7 +3072,7 @@
               </a:defRPr>
             </a:pPr>
             <a:r>
-              <a:t>Neither direction supplied a durable OOS edge</a:t>
+              <a:t>TRAIN’s long-side signal did not survive OOS—or ordinary costs</a:t>
             </a:r>
           </a:p>
         </p:txBody>
@@ -3086,11 +3086,11 @@
           <p:nvPr/>
         </p:nvPicPr>
         <p:blipFill>
-          <a:blip xmlns:r="http://schemas.openxmlformats.org/officeDocument/2006/relationships" xmlns:a="http://schemas.openxmlformats.org/drawingml/2006/main" r:embed="Rf4aba1fb84c04bc4"/>
+          <a:blip xmlns:r="http://schemas.openxmlformats.org/officeDocument/2006/relationships" xmlns:a="http://schemas.openxmlformats.org/drawingml/2006/main" r:embed="R166a7e0b10f8476a"/>
           <a:stretch xmlns:a="http://schemas.openxmlformats.org/drawingml/2006/main"/>
         </p:blipFill>
         <p:spPr>
-          <a:xfrm xmlns:a="http://schemas.openxmlformats.org/drawingml/2006/main">
+          <a:xfrm xmlns:a="http://schemas.openxmlformats.org/drawingml/2006/main" flipH="0" flipV="0">
             <a:off x="1190625" y="1162050"/>
             <a:ext cx="9810750" cy="4905375"/>
           </a:xfrm>
@@ -4038,7 +4038,7 @@
               </a:defRPr>
             </a:pPr>
             <a:r>
-              <a:t>Non-overlap protects the effective sample size</a:t>
+              <a:t>Spacing choices trade sample size for independence</a:t>
             </a:r>
           </a:p>
         </p:txBody>
@@ -4084,7 +4084,7 @@
               </a:defRPr>
             </a:pPr>
             <a:r>
-              <a:t>If adjacent labels reuse the same future days, the nominal observation count exaggerates independent evidence. Sparse anchors are for inference; daily overlapping sleeves are still allowed for the trading rule.</a:t>
+              <a:t>STEP_L directly answers a distinct-formation-episode question: one phase never reuses an L-session lookback. But H outcomes can still overlap—and, when H &lt; L, an outcome can enter the next lookback. Daily execution is a separate choice.</a:t>
             </a:r>
           </a:p>
         </p:txBody>
@@ -4176,7 +4176,7 @@
               </a:defRPr>
             </a:pPr>
             <a:r>
-              <a:t>Chan prose and Figure 6.1</a:t>
+              <a:t>Chan prose / shorter leg non-overlap</a:t>
             </a:r>
           </a:p>
           <a:p xmlns:a="http://schemas.openxmlformats.org/drawingml/2006/main">
@@ -4192,7 +4192,7 @@
               </a:defRPr>
             </a:pPr>
             <a:r>
-              <a:t>Shorter leg does not overlap</a:t>
+              <a:t>Most supported pairs</a:t>
             </a:r>
           </a:p>
         </p:txBody>
@@ -4238,7 +4238,7 @@
               </a:defRPr>
             </a:pPr>
             <a:r>
-              <a:t>step L+H</a:t>
+              <a:t>step L</a:t>
             </a:r>
           </a:p>
         </p:txBody>
@@ -4284,7 +4284,7 @@
               </a:defRPr>
             </a:pPr>
             <a:r>
-              <a:t>Strict sensitivity view</a:t>
+              <a:t>Distinct formation chunks</a:t>
             </a:r>
           </a:p>
           <a:p xmlns:a="http://schemas.openxmlformats.org/drawingml/2006/main">
@@ -4300,7 +4300,7 @@
               </a:defRPr>
             </a:pPr>
             <a:r>
-              <a:t>Neither return interval overlaps</a:t>
+              <a:t>H may overlap; phase matters</a:t>
             </a:r>
           </a:p>
         </p:txBody>
@@ -4346,7 +4346,7 @@
               </a:defRPr>
             </a:pPr>
             <a:r>
-              <a:t>daily sleeves</a:t>
+              <a:t>step L+H</a:t>
             </a:r>
           </a:p>
         </p:txBody>
@@ -4392,7 +4392,7 @@
               </a:defRPr>
             </a:pPr>
             <a:r>
-              <a:t>Trading may rebalance daily</a:t>
+              <a:t>No raw interval reused</a:t>
             </a:r>
           </a:p>
           <a:p xmlns:a="http://schemas.openxmlformats.org/drawingml/2006/main">
@@ -4408,7 +4408,7 @@
               </a:defRPr>
             </a:pPr>
             <a:r>
-              <a:t>That is not daily independent evidence</a:t>
+              <a:t>Strongest separation; fewest pairs</a:t>
             </a:r>
           </a:p>
         </p:txBody>
@@ -5089,7 +5089,7 @@
               </a:defRPr>
             </a:pPr>
             <a:r>
-              <a:t>One sign becomes H overlapping swing sleeves</a:t>
+              <a:t>Every close creates a new forecast—and one new sleeve</a:t>
             </a:r>
           </a:p>
         </p:txBody>
@@ -5170,7 +5170,7 @@
               </a:defRPr>
             </a:pPr>
             <a:r>
-              <a:t>s_t = sign(C_t / C_(t-L) - 1)</a:t>
+              <a:t>sₜ = sign(Cₜ / Cₜ₋ₗ − 1)</a:t>
             </a:r>
           </a:p>
           <a:p xmlns:a="http://schemas.openxmlformats.org/drawingml/2006/main">
@@ -5202,7 +5202,7 @@
               </a:defRPr>
             </a:pPr>
             <a:r>
-              <a:t>Start one sleeve of size 1/H each session.</a:t>
+              <a:t>After each close, recompute s_t from the newest L-session window.</a:t>
             </a:r>
           </a:p>
           <a:p xmlns:a="http://schemas.openxmlformats.org/drawingml/2006/main">
@@ -5218,7 +5218,7 @@
               </a:defRPr>
             </a:pPr>
             <a:r>
-              <a:t>Hold each sleeve for H opens.</a:t>
+              <a:t>At next open, add one sleeve of size 1/H.</a:t>
             </a:r>
           </a:p>
           <a:p xmlns:a="http://schemas.openxmlformats.org/drawingml/2006/main">
@@ -5234,7 +5234,7 @@
               </a:defRPr>
             </a:pPr>
             <a:r>
-              <a:t>Aggregate exposure: w_t = (1/H) Σ s_(t-h)</a:t>
+              <a:t>Each sleeve exits H opens after its own entry.</a:t>
             </a:r>
           </a:p>
           <a:p xmlns:a="http://schemas.openxmlformats.org/drawingml/2006/main">
@@ -5266,7 +5266,7 @@
               </a:defRPr>
             </a:pPr>
             <a:r>
-              <a:t>Signal after close; enter next open.</a:t>
+              <a:t>wₜ = (1/H) Σₕ₌₁ᴴ sₜ₋ₕ</a:t>
             </a:r>
           </a:p>
           <a:p xmlns:a="http://schemas.openxmlformats.org/drawingml/2006/main">
@@ -5282,7 +5282,7 @@
               </a:defRPr>
             </a:pPr>
             <a:r>
-              <a:t>Long when past return &gt; 0; short when &lt; 0.</a:t>
+              <a:t/>
             </a:r>
           </a:p>
           <a:p xmlns:a="http://schemas.openxmlformats.org/drawingml/2006/main">
@@ -5298,7 +5298,23 @@
               </a:defRPr>
             </a:pPr>
             <a:r>
-              <a:t>Primary cost: 5 bp per one-way net turnover.</a:t>
+              <a:t>Repeated signs are correlated updates—not independent confirmation.</a:t>
+            </a:r>
+          </a:p>
+          <a:p xmlns:a="http://schemas.openxmlformats.org/drawingml/2006/main">
+            <a:pPr algn="l">
+              <a:buNone/>
+              <a:defRPr sz="1950">
+                <a:solidFill>
+                  <a:srgbClr val="000000"/>
+                </a:solidFill>
+                <a:latin typeface="Helvetica Neue"/>
+                <a:ea typeface="Helvetica Neue"/>
+                <a:cs typeface="Helvetica Neue"/>
+              </a:defRPr>
+            </a:pPr>
+            <a:r>
+              <a:t>A reversal adds an opposing sleeve while older sleeves age out.</a:t>
             </a:r>
           </a:p>
         </p:txBody>
@@ -5345,11 +5361,11 @@
           <p:nvPr/>
         </p:nvPicPr>
         <p:blipFill>
-          <a:blip xmlns:r="http://schemas.openxmlformats.org/officeDocument/2006/relationships" xmlns:a="http://schemas.openxmlformats.org/drawingml/2006/main" r:embed="R3e7d004cdd6c4605"/>
+          <a:blip xmlns:r="http://schemas.openxmlformats.org/officeDocument/2006/relationships" xmlns:a="http://schemas.openxmlformats.org/drawingml/2006/main" r:embed="Rcb36f3062de94d04"/>
           <a:stretch xmlns:a="http://schemas.openxmlformats.org/drawingml/2006/main"/>
         </p:blipFill>
         <p:spPr>
-          <a:xfrm xmlns:a="http://schemas.openxmlformats.org/drawingml/2006/main">
+          <a:xfrm xmlns:a="http://schemas.openxmlformats.org/drawingml/2006/main" flipH="0" flipV="0">
             <a:off x="6381750" y="2009321"/>
             <a:ext cx="5238750" cy="2744107"/>
           </a:xfrm>
@@ -6617,7 +6633,7 @@
           <p:nvPr/>
         </p:nvPicPr>
         <p:blipFill>
-          <a:blip xmlns:r="http://schemas.openxmlformats.org/officeDocument/2006/relationships" xmlns:a="http://schemas.openxmlformats.org/drawingml/2006/main" r:embed="Re7591a70b9f741b1"/>
+          <a:blip xmlns:r="http://schemas.openxmlformats.org/officeDocument/2006/relationships" xmlns:a="http://schemas.openxmlformats.org/drawingml/2006/main" r:embed="R1abc5b9983464340"/>
           <a:stretch xmlns:a="http://schemas.openxmlformats.org/drawingml/2006/main"/>
         </p:blipFill>
         <p:spPr>
@@ -7071,7 +7087,7 @@
           <p:nvPr/>
         </p:nvPicPr>
         <p:blipFill>
-          <a:blip xmlns:r="http://schemas.openxmlformats.org/officeDocument/2006/relationships" xmlns:a="http://schemas.openxmlformats.org/drawingml/2006/main" r:embed="Rea471215755f4ae9"/>
+          <a:blip xmlns:r="http://schemas.openxmlformats.org/officeDocument/2006/relationships" xmlns:a="http://schemas.openxmlformats.org/drawingml/2006/main" r:embed="R4066ca337f7e48e0"/>
           <a:stretch xmlns:a="http://schemas.openxmlformats.org/drawingml/2006/main"/>
         </p:blipFill>
         <p:spPr>

</xml_diff>